<commit_message>
fix: version receipt verification and restore historical integrity
</commit_message>
<xml_diff>
--- a/gallery/onboarding-pilot/deck.pptx
+++ b/gallery/onboarding-pilot/deck.pptx
@@ -512,7 +512,7 @@
           </a:p>
           <a:p>
             <a:r>
-              <a:t>Support handoff review — Author-owned synthesis from recent customer handoffs. — Customer success lead</a:t>
+              <a:t>Support handoff review — Author-owned synthesis from recent customer handoffs. — owner Customer success lead — status unresolved — claims summary</a:t>
             </a:r>
           </a:p>
         </p:txBody>
@@ -587,7 +587,7 @@
           </a:p>
           <a:p>
             <a:r>
-              <a:t>Support handoff review — Author-owned synthesis from recent customer handoffs. — Customer success lead</a:t>
+              <a:t>Support handoff review — Author-owned synthesis from recent customer handoffs. — owner Customer success lead — status unresolved — claims summary</a:t>
             </a:r>
           </a:p>
         </p:txBody>
@@ -4351,14 +4351,14 @@
       </p:sp>
       <p:sp>
         <p:nvSpPr>
-          <p:cNvPr id="11" name="Rounded Rectangle 10"/>
+          <p:cNvPr id="11" name="semantic.standard.point.1"/>
           <p:cNvSpPr/>
           <p:nvPr/>
         </p:nvSpPr>
         <p:spPr>
           <a:xfrm>
-            <a:off x="548640" y="2971800"/>
-            <a:ext cx="7132320" cy="749808"/>
+            <a:off x="548640" y="2788920"/>
+            <a:ext cx="7132320" cy="768096"/>
           </a:xfrm>
           <a:prstGeom prst="roundRect">
             <a:avLst/>
@@ -4400,8 +4400,8 @@
         </p:nvSpPr>
         <p:spPr>
           <a:xfrm>
-            <a:off x="731520" y="3163824"/>
-            <a:ext cx="493776" cy="274320"/>
+            <a:off x="713232" y="2953512"/>
+            <a:ext cx="475488" cy="237744"/>
           </a:xfrm>
           <a:prstGeom prst="rect">
             <a:avLst/>
@@ -4416,7 +4416,7 @@
           <a:p>
             <a:pPr algn="l"/>
             <a:r>
-              <a:rPr sz="1200" b="1">
+              <a:rPr sz="1100" b="1">
                 <a:solidFill>
                   <a:srgbClr val="E5B560"/>
                 </a:solidFill>
@@ -4435,8 +4435,8 @@
         </p:nvSpPr>
         <p:spPr>
           <a:xfrm>
-            <a:off x="1261872" y="3108960"/>
-            <a:ext cx="2240280" cy="283464"/>
+            <a:off x="1243584" y="2898648"/>
+            <a:ext cx="2057400" cy="274320"/>
           </a:xfrm>
           <a:prstGeom prst="rect">
             <a:avLst/>
@@ -4451,7 +4451,7 @@
           <a:p>
             <a:pPr algn="l"/>
             <a:r>
-              <a:rPr sz="1600" b="1">
+              <a:rPr sz="1500" b="1">
                 <a:solidFill>
                   <a:srgbClr val="F7F4EE"/>
                 </a:solidFill>
@@ -4470,8 +4470,8 @@
         </p:nvSpPr>
         <p:spPr>
           <a:xfrm>
-            <a:off x="3547872" y="3108960"/>
-            <a:ext cx="3950208" cy="347472"/>
+            <a:off x="3337560" y="2898648"/>
+            <a:ext cx="4169664" cy="365760"/>
           </a:xfrm>
           <a:prstGeom prst="rect">
             <a:avLst/>
@@ -4486,7 +4486,7 @@
           <a:p>
             <a:pPr algn="l"/>
             <a:r>
-              <a:rPr sz="1500" b="0">
+              <a:rPr sz="1300" b="0">
                 <a:solidFill>
                   <a:srgbClr val="B8C0D6"/>
                 </a:solidFill>
@@ -4499,14 +4499,14 @@
       </p:sp>
       <p:sp>
         <p:nvSpPr>
-          <p:cNvPr id="15" name="Rounded Rectangle 14"/>
+          <p:cNvPr id="15" name="semantic.standard.point.2"/>
           <p:cNvSpPr/>
           <p:nvPr/>
         </p:nvSpPr>
         <p:spPr>
           <a:xfrm>
-            <a:off x="548640" y="3959352"/>
-            <a:ext cx="7132320" cy="749808"/>
+            <a:off x="548640" y="3703320"/>
+            <a:ext cx="7132320" cy="768096"/>
           </a:xfrm>
           <a:prstGeom prst="roundRect">
             <a:avLst/>
@@ -4548,8 +4548,8 @@
         </p:nvSpPr>
         <p:spPr>
           <a:xfrm>
-            <a:off x="731520" y="4151376"/>
-            <a:ext cx="493776" cy="274320"/>
+            <a:off x="713232" y="3867912"/>
+            <a:ext cx="475488" cy="237744"/>
           </a:xfrm>
           <a:prstGeom prst="rect">
             <a:avLst/>
@@ -4564,7 +4564,7 @@
           <a:p>
             <a:pPr algn="l"/>
             <a:r>
-              <a:rPr sz="1200" b="1">
+              <a:rPr sz="1100" b="1">
                 <a:solidFill>
                   <a:srgbClr val="E5B560"/>
                 </a:solidFill>
@@ -4583,8 +4583,8 @@
         </p:nvSpPr>
         <p:spPr>
           <a:xfrm>
-            <a:off x="1261872" y="4096512"/>
-            <a:ext cx="2240280" cy="283464"/>
+            <a:off x="1243584" y="3813048"/>
+            <a:ext cx="2057400" cy="274320"/>
           </a:xfrm>
           <a:prstGeom prst="rect">
             <a:avLst/>
@@ -4599,7 +4599,7 @@
           <a:p>
             <a:pPr algn="l"/>
             <a:r>
-              <a:rPr sz="1600" b="1">
+              <a:rPr sz="1500" b="1">
                 <a:solidFill>
                   <a:srgbClr val="F7F4EE"/>
                 </a:solidFill>
@@ -4618,8 +4618,8 @@
         </p:nvSpPr>
         <p:spPr>
           <a:xfrm>
-            <a:off x="3547872" y="4096512"/>
-            <a:ext cx="3950208" cy="347472"/>
+            <a:off x="3337560" y="3813048"/>
+            <a:ext cx="4169664" cy="365760"/>
           </a:xfrm>
           <a:prstGeom prst="rect">
             <a:avLst/>
@@ -4634,7 +4634,7 @@
           <a:p>
             <a:pPr algn="l"/>
             <a:r>
-              <a:rPr sz="1500" b="0">
+              <a:rPr sz="1300" b="0">
                 <a:solidFill>
                   <a:srgbClr val="B8C0D6"/>
                 </a:solidFill>
@@ -4647,14 +4647,14 @@
       </p:sp>
       <p:sp>
         <p:nvSpPr>
-          <p:cNvPr id="19" name="Rounded Rectangle 18"/>
+          <p:cNvPr id="19" name="semantic.standard.point.3"/>
           <p:cNvSpPr/>
           <p:nvPr/>
         </p:nvSpPr>
         <p:spPr>
           <a:xfrm>
-            <a:off x="548640" y="4946904"/>
-            <a:ext cx="7132320" cy="749808"/>
+            <a:off x="548640" y="4617720"/>
+            <a:ext cx="7132320" cy="768096"/>
           </a:xfrm>
           <a:prstGeom prst="roundRect">
             <a:avLst/>
@@ -4696,8 +4696,8 @@
         </p:nvSpPr>
         <p:spPr>
           <a:xfrm>
-            <a:off x="731520" y="5138928"/>
-            <a:ext cx="493776" cy="274320"/>
+            <a:off x="713232" y="4782312"/>
+            <a:ext cx="475488" cy="237744"/>
           </a:xfrm>
           <a:prstGeom prst="rect">
             <a:avLst/>
@@ -4712,7 +4712,7 @@
           <a:p>
             <a:pPr algn="l"/>
             <a:r>
-              <a:rPr sz="1200" b="1">
+              <a:rPr sz="1100" b="1">
                 <a:solidFill>
                   <a:srgbClr val="E5B560"/>
                 </a:solidFill>
@@ -4731,8 +4731,8 @@
         </p:nvSpPr>
         <p:spPr>
           <a:xfrm>
-            <a:off x="1261872" y="5084064"/>
-            <a:ext cx="2240280" cy="283464"/>
+            <a:off x="1243584" y="4727448"/>
+            <a:ext cx="2057400" cy="274320"/>
           </a:xfrm>
           <a:prstGeom prst="rect">
             <a:avLst/>
@@ -4747,7 +4747,7 @@
           <a:p>
             <a:pPr algn="l"/>
             <a:r>
-              <a:rPr sz="1600" b="1">
+              <a:rPr sz="1500" b="1">
                 <a:solidFill>
                   <a:srgbClr val="F7F4EE"/>
                 </a:solidFill>
@@ -4766,8 +4766,8 @@
         </p:nvSpPr>
         <p:spPr>
           <a:xfrm>
-            <a:off x="3547872" y="5084064"/>
-            <a:ext cx="3950208" cy="347472"/>
+            <a:off x="3337560" y="4727448"/>
+            <a:ext cx="4169664" cy="365760"/>
           </a:xfrm>
           <a:prstGeom prst="rect">
             <a:avLst/>
@@ -4782,7 +4782,7 @@
           <a:p>
             <a:pPr algn="l"/>
             <a:r>
-              <a:rPr sz="1500" b="0">
+              <a:rPr sz="1300" b="0">
                 <a:solidFill>
                   <a:srgbClr val="B8C0D6"/>
                 </a:solidFill>
@@ -4836,7 +4836,7 @@
         </p:nvSpPr>
         <p:spPr>
           <a:xfrm>
-            <a:off x="11064240" y="6428232"/>
+            <a:off x="11094415" y="6428232"/>
             <a:ext cx="594360" cy="201168"/>
           </a:xfrm>
           <a:prstGeom prst="rect">
@@ -5188,27 +5188,62 @@
                 </a:solidFill>
                 <a:latin typeface="Aptos"/>
               </a:rPr>
-              <a:t>COMPARE</a:t>
-            </a:r>
-          </a:p>
-        </p:txBody>
-      </p:sp>
-      <p:sp>
-        <p:nvSpPr>
-          <p:cNvPr id="10" name="Rectangle 9"/>
+              <a:t>KEY FRAME</a:t>
+            </a:r>
+          </a:p>
+        </p:txBody>
+      </p:sp>
+      <p:sp>
+        <p:nvSpPr>
+          <p:cNvPr id="10" name="TextBox 9"/>
+          <p:cNvSpPr txBox="1"/>
+          <p:nvPr/>
+        </p:nvSpPr>
+        <p:spPr>
+          <a:xfrm>
+            <a:off x="859536" y="3913632"/>
+            <a:ext cx="2578608" cy="1024128"/>
+          </a:xfrm>
+          <a:prstGeom prst="rect">
+            <a:avLst/>
+          </a:prstGeom>
+          <a:noFill/>
+        </p:spPr>
+        <p:txBody>
+          <a:bodyPr wrap="square" lIns="0" rIns="0" tIns="0" bIns="0" anchor="t">
+            <a:spAutoFit/>
+          </a:bodyPr>
+          <a:lstStyle/>
+          <a:p>
+            <a:pPr algn="l"/>
+            <a:r>
+              <a:rPr sz="1900" b="1">
+                <a:solidFill>
+                  <a:srgbClr val="F7F4EE"/>
+                </a:solidFill>
+                <a:latin typeface="Aptos Display"/>
+              </a:rPr>
+              <a:t>The boundaries that matter</a:t>
+            </a:r>
+          </a:p>
+        </p:txBody>
+      </p:sp>
+      <p:sp>
+        <p:nvSpPr>
+          <p:cNvPr id="11" name="semantic.standard.point.1"/>
           <p:cNvSpPr/>
           <p:nvPr/>
         </p:nvSpPr>
         <p:spPr>
           <a:xfrm>
-            <a:off x="859536" y="4709160"/>
-            <a:ext cx="1243584" cy="502920"/>
-          </a:xfrm>
-          <a:prstGeom prst="rect">
+            <a:off x="4160520" y="2788920"/>
+            <a:ext cx="7132320" cy="768096"/>
+          </a:xfrm>
+          <a:prstGeom prst="roundRect">
             <a:avLst/>
           </a:prstGeom>
           <a:solidFill>
-            <a:srgbClr val="E5B560"/>
+            <a:srgbClr val="1B2136"/>
           </a:solidFill>
           <a:ln>
             <a:noFill/>
@@ -5238,14 +5273,14 @@
       </p:sp>
       <p:sp>
         <p:nvSpPr>
-          <p:cNvPr id="11" name="TextBox 10"/>
+          <p:cNvPr id="12" name="TextBox 11"/>
           <p:cNvSpPr txBox="1"/>
           <p:nvPr/>
         </p:nvSpPr>
         <p:spPr>
           <a:xfrm>
-            <a:off x="859536" y="4818888"/>
-            <a:ext cx="1243584" cy="228600"/>
+            <a:off x="4325112" y="2953512"/>
+            <a:ext cx="475488" cy="237744"/>
           </a:xfrm>
           <a:prstGeom prst="rect">
             <a:avLst/>
@@ -5258,31 +5293,101 @@
           </a:bodyPr>
           <a:lstStyle/>
           <a:p>
-            <a:pPr algn="ctr"/>
-            <a:r>
-              <a:rPr sz="900" b="1">
-                <a:solidFill>
-                  <a:srgbClr val="F7F4EE"/>
+            <a:pPr algn="l"/>
+            <a:r>
+              <a:rPr sz="1100" b="1">
+                <a:solidFill>
+                  <a:srgbClr val="E5B560"/>
                 </a:solidFill>
                 <a:latin typeface="Aptos"/>
               </a:rPr>
-              <a:t>BEFORE</a:t>
-            </a:r>
-          </a:p>
-        </p:txBody>
-      </p:sp>
-      <p:sp>
-        <p:nvSpPr>
-          <p:cNvPr id="12" name="Rectangle 11"/>
+              <a:t>01</a:t>
+            </a:r>
+          </a:p>
+        </p:txBody>
+      </p:sp>
+      <p:sp>
+        <p:nvSpPr>
+          <p:cNvPr id="13" name="TextBox 12"/>
+          <p:cNvSpPr txBox="1"/>
+          <p:nvPr/>
+        </p:nvSpPr>
+        <p:spPr>
+          <a:xfrm>
+            <a:off x="4855464" y="2898648"/>
+            <a:ext cx="2057400" cy="274320"/>
+          </a:xfrm>
+          <a:prstGeom prst="rect">
+            <a:avLst/>
+          </a:prstGeom>
+          <a:noFill/>
+        </p:spPr>
+        <p:txBody>
+          <a:bodyPr wrap="square" lIns="0" rIns="0" tIns="0" bIns="0" anchor="t">
+            <a:spAutoFit/>
+          </a:bodyPr>
+          <a:lstStyle/>
+          <a:p>
+            <a:pPr algn="l"/>
+            <a:r>
+              <a:rPr sz="1500" b="1">
+                <a:solidFill>
+                  <a:srgbClr val="F7F4EE"/>
+                </a:solidFill>
+                <a:latin typeface="Aptos"/>
+              </a:rPr>
+              <a:t>Constraint 1</a:t>
+            </a:r>
+          </a:p>
+        </p:txBody>
+      </p:sp>
+      <p:sp>
+        <p:nvSpPr>
+          <p:cNvPr id="14" name="TextBox 13"/>
+          <p:cNvSpPr txBox="1"/>
+          <p:nvPr/>
+        </p:nvSpPr>
+        <p:spPr>
+          <a:xfrm>
+            <a:off x="6949440" y="2898648"/>
+            <a:ext cx="4169664" cy="365760"/>
+          </a:xfrm>
+          <a:prstGeom prst="rect">
+            <a:avLst/>
+          </a:prstGeom>
+          <a:noFill/>
+        </p:spPr>
+        <p:txBody>
+          <a:bodyPr wrap="square" lIns="0" rIns="0" tIns="0" bIns="0" anchor="t">
+            <a:spAutoFit/>
+          </a:bodyPr>
+          <a:lstStyle/>
+          <a:p>
+            <a:pPr algn="l"/>
+            <a:r>
+              <a:rPr sz="1300" b="0">
+                <a:solidFill>
+                  <a:srgbClr val="B8C0D6"/>
+                </a:solidFill>
+                <a:latin typeface="Aptos"/>
+              </a:rPr>
+              <a:t>No new platform</a:t>
+            </a:r>
+          </a:p>
+        </p:txBody>
+      </p:sp>
+      <p:sp>
+        <p:nvSpPr>
+          <p:cNvPr id="15" name="semantic.standard.point.2"/>
           <p:cNvSpPr/>
           <p:nvPr/>
         </p:nvSpPr>
         <p:spPr>
           <a:xfrm>
-            <a:off x="2194560" y="4709160"/>
-            <a:ext cx="1243584" cy="502920"/>
-          </a:xfrm>
-          <a:prstGeom prst="rect">
+            <a:off x="4160520" y="3703320"/>
+            <a:ext cx="7132320" cy="768096"/>
+          </a:xfrm>
+          <a:prstGeom prst="roundRect">
             <a:avLst/>
           </a:prstGeom>
           <a:solidFill>
@@ -5316,14 +5421,14 @@
       </p:sp>
       <p:sp>
         <p:nvSpPr>
-          <p:cNvPr id="13" name="TextBox 12"/>
+          <p:cNvPr id="16" name="TextBox 15"/>
           <p:cNvSpPr txBox="1"/>
           <p:nvPr/>
         </p:nvSpPr>
         <p:spPr>
           <a:xfrm>
-            <a:off x="2194560" y="4818888"/>
-            <a:ext cx="1243584" cy="228600"/>
+            <a:off x="4325112" y="3867912"/>
+            <a:ext cx="475488" cy="237744"/>
           </a:xfrm>
           <a:prstGeom prst="rect">
             <a:avLst/>
@@ -5336,29 +5441,29 @@
           </a:bodyPr>
           <a:lstStyle/>
           <a:p>
-            <a:pPr algn="ctr"/>
-            <a:r>
-              <a:rPr sz="900" b="1">
-                <a:solidFill>
-                  <a:srgbClr val="F7F4EE"/>
+            <a:pPr algn="l"/>
+            <a:r>
+              <a:rPr sz="1100" b="1">
+                <a:solidFill>
+                  <a:srgbClr val="E5B560"/>
                 </a:solidFill>
                 <a:latin typeface="Aptos"/>
               </a:rPr>
-              <a:t>AFTER</a:t>
-            </a:r>
-          </a:p>
-        </p:txBody>
-      </p:sp>
-      <p:sp>
-        <p:nvSpPr>
-          <p:cNvPr id="14" name="TextBox 13"/>
+              <a:t>02</a:t>
+            </a:r>
+          </a:p>
+        </p:txBody>
+      </p:sp>
+      <p:sp>
+        <p:nvSpPr>
+          <p:cNvPr id="17" name="TextBox 16"/>
           <p:cNvSpPr txBox="1"/>
           <p:nvPr/>
         </p:nvSpPr>
         <p:spPr>
           <a:xfrm>
-            <a:off x="859536" y="3913632"/>
-            <a:ext cx="2578608" cy="1024128"/>
+            <a:off x="4855464" y="3813048"/>
+            <a:ext cx="2057400" cy="274320"/>
           </a:xfrm>
           <a:prstGeom prst="rect">
             <a:avLst/>
@@ -5373,27 +5478,62 @@
           <a:p>
             <a:pPr algn="l"/>
             <a:r>
-              <a:rPr sz="1900" b="1">
+              <a:rPr sz="1500" b="1">
                 <a:solidFill>
                   <a:srgbClr val="F7F4EE"/>
                 </a:solidFill>
-                <a:latin typeface="Aptos Display"/>
+                <a:latin typeface="Aptos"/>
               </a:rPr>
-              <a:t>The boundaries that matter</a:t>
-            </a:r>
-          </a:p>
-        </p:txBody>
-      </p:sp>
-      <p:sp>
-        <p:nvSpPr>
-          <p:cNvPr id="15" name="Rounded Rectangle 14"/>
+              <a:t>Constraint 2</a:t>
+            </a:r>
+          </a:p>
+        </p:txBody>
+      </p:sp>
+      <p:sp>
+        <p:nvSpPr>
+          <p:cNvPr id="18" name="TextBox 17"/>
+          <p:cNvSpPr txBox="1"/>
+          <p:nvPr/>
+        </p:nvSpPr>
+        <p:spPr>
+          <a:xfrm>
+            <a:off x="6949440" y="3813048"/>
+            <a:ext cx="4169664" cy="365760"/>
+          </a:xfrm>
+          <a:prstGeom prst="rect">
+            <a:avLst/>
+          </a:prstGeom>
+          <a:noFill/>
+        </p:spPr>
+        <p:txBody>
+          <a:bodyPr wrap="square" lIns="0" rIns="0" tIns="0" bIns="0" anchor="t">
+            <a:spAutoFit/>
+          </a:bodyPr>
+          <a:lstStyle/>
+          <a:p>
+            <a:pPr algn="l"/>
+            <a:r>
+              <a:rPr sz="1300" b="0">
+                <a:solidFill>
+                  <a:srgbClr val="B8C0D6"/>
+                </a:solidFill>
+                <a:latin typeface="Aptos"/>
+              </a:rPr>
+              <a:t>One product team</a:t>
+            </a:r>
+          </a:p>
+        </p:txBody>
+      </p:sp>
+      <p:sp>
+        <p:nvSpPr>
+          <p:cNvPr id="19" name="semantic.standard.point.3"/>
           <p:cNvSpPr/>
           <p:nvPr/>
         </p:nvSpPr>
         <p:spPr>
           <a:xfrm>
-            <a:off x="4160520" y="2971800"/>
-            <a:ext cx="7132320" cy="749808"/>
+            <a:off x="4160520" y="4617720"/>
+            <a:ext cx="7132320" cy="768096"/>
           </a:xfrm>
           <a:prstGeom prst="roundRect">
             <a:avLst/>
@@ -5429,14 +5569,14 @@
       </p:sp>
       <p:sp>
         <p:nvSpPr>
-          <p:cNvPr id="16" name="TextBox 15"/>
+          <p:cNvPr id="20" name="TextBox 19"/>
           <p:cNvSpPr txBox="1"/>
           <p:nvPr/>
         </p:nvSpPr>
         <p:spPr>
           <a:xfrm>
-            <a:off x="4343400" y="3163824"/>
-            <a:ext cx="493776" cy="274320"/>
+            <a:off x="4325112" y="4782312"/>
+            <a:ext cx="475488" cy="237744"/>
           </a:xfrm>
           <a:prstGeom prst="rect">
             <a:avLst/>
@@ -5451,27 +5591,27 @@
           <a:p>
             <a:pPr algn="l"/>
             <a:r>
-              <a:rPr sz="1200" b="1">
+              <a:rPr sz="1100" b="1">
                 <a:solidFill>
                   <a:srgbClr val="E5B560"/>
                 </a:solidFill>
                 <a:latin typeface="Aptos"/>
               </a:rPr>
-              <a:t>01</a:t>
-            </a:r>
-          </a:p>
-        </p:txBody>
-      </p:sp>
-      <p:sp>
-        <p:nvSpPr>
-          <p:cNvPr id="17" name="TextBox 16"/>
+              <a:t>03</a:t>
+            </a:r>
+          </a:p>
+        </p:txBody>
+      </p:sp>
+      <p:sp>
+        <p:nvSpPr>
+          <p:cNvPr id="21" name="TextBox 20"/>
           <p:cNvSpPr txBox="1"/>
           <p:nvPr/>
         </p:nvSpPr>
         <p:spPr>
           <a:xfrm>
-            <a:off x="4873752" y="3108960"/>
-            <a:ext cx="2240280" cy="283464"/>
+            <a:off x="4855464" y="4727448"/>
+            <a:ext cx="2057400" cy="274320"/>
           </a:xfrm>
           <a:prstGeom prst="rect">
             <a:avLst/>
@@ -5486,27 +5626,27 @@
           <a:p>
             <a:pPr algn="l"/>
             <a:r>
-              <a:rPr sz="1600" b="1">
+              <a:rPr sz="1500" b="1">
                 <a:solidFill>
                   <a:srgbClr val="F7F4EE"/>
                 </a:solidFill>
                 <a:latin typeface="Aptos"/>
               </a:rPr>
-              <a:t>Constraint 1</a:t>
-            </a:r>
-          </a:p>
-        </p:txBody>
-      </p:sp>
-      <p:sp>
-        <p:nvSpPr>
-          <p:cNvPr id="18" name="TextBox 17"/>
+              <a:t>Constraint 3</a:t>
+            </a:r>
+          </a:p>
+        </p:txBody>
+      </p:sp>
+      <p:sp>
+        <p:nvSpPr>
+          <p:cNvPr id="22" name="TextBox 21"/>
           <p:cNvSpPr txBox="1"/>
           <p:nvPr/>
         </p:nvSpPr>
         <p:spPr>
           <a:xfrm>
-            <a:off x="7159752" y="3108960"/>
-            <a:ext cx="3950208" cy="347472"/>
+            <a:off x="6949440" y="4727448"/>
+            <a:ext cx="4169664" cy="365760"/>
           </a:xfrm>
           <a:prstGeom prst="rect">
             <a:avLst/>
@@ -5521,70 +5661,27 @@
           <a:p>
             <a:pPr algn="l"/>
             <a:r>
-              <a:rPr sz="1500" b="0">
+              <a:rPr sz="1300" b="0">
                 <a:solidFill>
                   <a:srgbClr val="B8C0D6"/>
                 </a:solidFill>
                 <a:latin typeface="Aptos"/>
               </a:rPr>
-              <a:t>No new platform</a:t>
-            </a:r>
-          </a:p>
-        </p:txBody>
-      </p:sp>
-      <p:sp>
-        <p:nvSpPr>
-          <p:cNvPr id="19" name="Rounded Rectangle 18"/>
-          <p:cNvSpPr/>
-          <p:nvPr/>
-        </p:nvSpPr>
-        <p:spPr>
-          <a:xfrm>
-            <a:off x="4160520" y="3959352"/>
-            <a:ext cx="7132320" cy="749808"/>
-          </a:xfrm>
-          <a:prstGeom prst="roundRect">
-            <a:avLst/>
-          </a:prstGeom>
-          <a:solidFill>
-            <a:srgbClr val="262E49"/>
-          </a:solidFill>
-          <a:ln>
-            <a:noFill/>
-          </a:ln>
-        </p:spPr>
-        <p:style>
-          <a:lnRef idx="1">
-            <a:schemeClr val="accent1"/>
-          </a:lnRef>
-          <a:fillRef idx="3">
-            <a:schemeClr val="accent1"/>
-          </a:fillRef>
-          <a:effectRef idx="2">
-            <a:schemeClr val="accent1"/>
-          </a:effectRef>
-          <a:fontRef idx="minor">
-            <a:schemeClr val="lt1"/>
-          </a:fontRef>
-        </p:style>
-        <p:txBody>
-          <a:bodyPr rtlCol="0" anchor="ctr"/>
-          <a:lstStyle/>
-          <a:p>
-            <a:pPr algn="ctr"/>
-          </a:p>
-        </p:txBody>
-      </p:sp>
-      <p:sp>
-        <p:nvSpPr>
-          <p:cNvPr id="20" name="TextBox 19"/>
+              <a:t>Six-week pilot</a:t>
+            </a:r>
+          </a:p>
+        </p:txBody>
+      </p:sp>
+      <p:sp>
+        <p:nvSpPr>
+          <p:cNvPr id="23" name="TextBox 22"/>
           <p:cNvSpPr txBox="1"/>
           <p:nvPr/>
         </p:nvSpPr>
         <p:spPr>
           <a:xfrm>
-            <a:off x="4343400" y="4151376"/>
-            <a:ext cx="493776" cy="274320"/>
+            <a:off x="502920" y="6446520"/>
+            <a:ext cx="5669280" cy="201168"/>
           </a:xfrm>
           <a:prstGeom prst="rect">
             <a:avLst/>
@@ -5599,259 +5696,6 @@
           <a:p>
             <a:pPr algn="l"/>
             <a:r>
-              <a:rPr sz="1200" b="1">
-                <a:solidFill>
-                  <a:srgbClr val="E5B560"/>
-                </a:solidFill>
-                <a:latin typeface="Aptos"/>
-              </a:rPr>
-              <a:t>02</a:t>
-            </a:r>
-          </a:p>
-        </p:txBody>
-      </p:sp>
-      <p:sp>
-        <p:nvSpPr>
-          <p:cNvPr id="21" name="TextBox 20"/>
-          <p:cNvSpPr txBox="1"/>
-          <p:nvPr/>
-        </p:nvSpPr>
-        <p:spPr>
-          <a:xfrm>
-            <a:off x="4873752" y="4096512"/>
-            <a:ext cx="2240280" cy="283464"/>
-          </a:xfrm>
-          <a:prstGeom prst="rect">
-            <a:avLst/>
-          </a:prstGeom>
-          <a:noFill/>
-        </p:spPr>
-        <p:txBody>
-          <a:bodyPr wrap="square" lIns="0" rIns="0" tIns="0" bIns="0" anchor="t">
-            <a:spAutoFit/>
-          </a:bodyPr>
-          <a:lstStyle/>
-          <a:p>
-            <a:pPr algn="l"/>
-            <a:r>
-              <a:rPr sz="1600" b="1">
-                <a:solidFill>
-                  <a:srgbClr val="F7F4EE"/>
-                </a:solidFill>
-                <a:latin typeface="Aptos"/>
-              </a:rPr>
-              <a:t>Constraint 2</a:t>
-            </a:r>
-          </a:p>
-        </p:txBody>
-      </p:sp>
-      <p:sp>
-        <p:nvSpPr>
-          <p:cNvPr id="22" name="TextBox 21"/>
-          <p:cNvSpPr txBox="1"/>
-          <p:nvPr/>
-        </p:nvSpPr>
-        <p:spPr>
-          <a:xfrm>
-            <a:off x="7159752" y="4096512"/>
-            <a:ext cx="3950208" cy="347472"/>
-          </a:xfrm>
-          <a:prstGeom prst="rect">
-            <a:avLst/>
-          </a:prstGeom>
-          <a:noFill/>
-        </p:spPr>
-        <p:txBody>
-          <a:bodyPr wrap="square" lIns="0" rIns="0" tIns="0" bIns="0" anchor="t">
-            <a:spAutoFit/>
-          </a:bodyPr>
-          <a:lstStyle/>
-          <a:p>
-            <a:pPr algn="l"/>
-            <a:r>
-              <a:rPr sz="1500" b="0">
-                <a:solidFill>
-                  <a:srgbClr val="B8C0D6"/>
-                </a:solidFill>
-                <a:latin typeface="Aptos"/>
-              </a:rPr>
-              <a:t>One product team</a:t>
-            </a:r>
-          </a:p>
-        </p:txBody>
-      </p:sp>
-      <p:sp>
-        <p:nvSpPr>
-          <p:cNvPr id="23" name="Rounded Rectangle 22"/>
-          <p:cNvSpPr/>
-          <p:nvPr/>
-        </p:nvSpPr>
-        <p:spPr>
-          <a:xfrm>
-            <a:off x="4160520" y="4946904"/>
-            <a:ext cx="7132320" cy="749808"/>
-          </a:xfrm>
-          <a:prstGeom prst="roundRect">
-            <a:avLst/>
-          </a:prstGeom>
-          <a:solidFill>
-            <a:srgbClr val="1B2136"/>
-          </a:solidFill>
-          <a:ln>
-            <a:noFill/>
-          </a:ln>
-        </p:spPr>
-        <p:style>
-          <a:lnRef idx="1">
-            <a:schemeClr val="accent1"/>
-          </a:lnRef>
-          <a:fillRef idx="3">
-            <a:schemeClr val="accent1"/>
-          </a:fillRef>
-          <a:effectRef idx="2">
-            <a:schemeClr val="accent1"/>
-          </a:effectRef>
-          <a:fontRef idx="minor">
-            <a:schemeClr val="lt1"/>
-          </a:fontRef>
-        </p:style>
-        <p:txBody>
-          <a:bodyPr rtlCol="0" anchor="ctr"/>
-          <a:lstStyle/>
-          <a:p>
-            <a:pPr algn="ctr"/>
-          </a:p>
-        </p:txBody>
-      </p:sp>
-      <p:sp>
-        <p:nvSpPr>
-          <p:cNvPr id="24" name="TextBox 23"/>
-          <p:cNvSpPr txBox="1"/>
-          <p:nvPr/>
-        </p:nvSpPr>
-        <p:spPr>
-          <a:xfrm>
-            <a:off x="4343400" y="5138928"/>
-            <a:ext cx="493776" cy="274320"/>
-          </a:xfrm>
-          <a:prstGeom prst="rect">
-            <a:avLst/>
-          </a:prstGeom>
-          <a:noFill/>
-        </p:spPr>
-        <p:txBody>
-          <a:bodyPr wrap="square" lIns="0" rIns="0" tIns="0" bIns="0" anchor="t">
-            <a:spAutoFit/>
-          </a:bodyPr>
-          <a:lstStyle/>
-          <a:p>
-            <a:pPr algn="l"/>
-            <a:r>
-              <a:rPr sz="1200" b="1">
-                <a:solidFill>
-                  <a:srgbClr val="E5B560"/>
-                </a:solidFill>
-                <a:latin typeface="Aptos"/>
-              </a:rPr>
-              <a:t>03</a:t>
-            </a:r>
-          </a:p>
-        </p:txBody>
-      </p:sp>
-      <p:sp>
-        <p:nvSpPr>
-          <p:cNvPr id="25" name="TextBox 24"/>
-          <p:cNvSpPr txBox="1"/>
-          <p:nvPr/>
-        </p:nvSpPr>
-        <p:spPr>
-          <a:xfrm>
-            <a:off x="4873752" y="5084064"/>
-            <a:ext cx="2240280" cy="283464"/>
-          </a:xfrm>
-          <a:prstGeom prst="rect">
-            <a:avLst/>
-          </a:prstGeom>
-          <a:noFill/>
-        </p:spPr>
-        <p:txBody>
-          <a:bodyPr wrap="square" lIns="0" rIns="0" tIns="0" bIns="0" anchor="t">
-            <a:spAutoFit/>
-          </a:bodyPr>
-          <a:lstStyle/>
-          <a:p>
-            <a:pPr algn="l"/>
-            <a:r>
-              <a:rPr sz="1600" b="1">
-                <a:solidFill>
-                  <a:srgbClr val="F7F4EE"/>
-                </a:solidFill>
-                <a:latin typeface="Aptos"/>
-              </a:rPr>
-              <a:t>Constraint 3</a:t>
-            </a:r>
-          </a:p>
-        </p:txBody>
-      </p:sp>
-      <p:sp>
-        <p:nvSpPr>
-          <p:cNvPr id="26" name="TextBox 25"/>
-          <p:cNvSpPr txBox="1"/>
-          <p:nvPr/>
-        </p:nvSpPr>
-        <p:spPr>
-          <a:xfrm>
-            <a:off x="7159752" y="5084064"/>
-            <a:ext cx="3950208" cy="347472"/>
-          </a:xfrm>
-          <a:prstGeom prst="rect">
-            <a:avLst/>
-          </a:prstGeom>
-          <a:noFill/>
-        </p:spPr>
-        <p:txBody>
-          <a:bodyPr wrap="square" lIns="0" rIns="0" tIns="0" bIns="0" anchor="t">
-            <a:spAutoFit/>
-          </a:bodyPr>
-          <a:lstStyle/>
-          <a:p>
-            <a:pPr algn="l"/>
-            <a:r>
-              <a:rPr sz="1500" b="0">
-                <a:solidFill>
-                  <a:srgbClr val="B8C0D6"/>
-                </a:solidFill>
-                <a:latin typeface="Aptos"/>
-              </a:rPr>
-              <a:t>Six-week pilot</a:t>
-            </a:r>
-          </a:p>
-        </p:txBody>
-      </p:sp>
-      <p:sp>
-        <p:nvSpPr>
-          <p:cNvPr id="27" name="TextBox 26"/>
-          <p:cNvSpPr txBox="1"/>
-          <p:nvPr/>
-        </p:nvSpPr>
-        <p:spPr>
-          <a:xfrm>
-            <a:off x="502920" y="6446520"/>
-            <a:ext cx="5669280" cy="201168"/>
-          </a:xfrm>
-          <a:prstGeom prst="rect">
-            <a:avLst/>
-          </a:prstGeom>
-          <a:noFill/>
-        </p:spPr>
-        <p:txBody>
-          <a:bodyPr wrap="square" lIns="0" rIns="0" tIns="0" bIns="0" anchor="t">
-            <a:spAutoFit/>
-          </a:bodyPr>
-          <a:lstStyle/>
-          <a:p>
-            <a:pPr algn="l"/>
-            <a:r>
               <a:rPr sz="900" b="0">
                 <a:solidFill>
                   <a:srgbClr val="B8C0D6"/>
@@ -5865,13 +5709,13 @@
       </p:sp>
       <p:sp>
         <p:nvSpPr>
-          <p:cNvPr id="28" name="TextBox 27"/>
+          <p:cNvPr id="24" name="TextBox 23"/>
           <p:cNvSpPr txBox="1"/>
           <p:nvPr/>
         </p:nvSpPr>
         <p:spPr>
           <a:xfrm>
-            <a:off x="11064240" y="6428232"/>
+            <a:off x="11094415" y="6428232"/>
             <a:ext cx="594360" cy="201168"/>
           </a:xfrm>
           <a:prstGeom prst="rect">
@@ -6421,16 +6265,16 @@
       </p:sp>
       <p:sp>
         <p:nvSpPr>
-          <p:cNvPr id="15" name="Rounded Rectangle 14"/>
+          <p:cNvPr id="15" name="semantic.comparison.side.1"/>
           <p:cNvSpPr/>
           <p:nvPr/>
         </p:nvSpPr>
         <p:spPr>
           <a:xfrm>
-            <a:off x="548640" y="2971800"/>
-            <a:ext cx="7543800" cy="749808"/>
-          </a:xfrm>
-          <a:prstGeom prst="roundRect">
+            <a:off x="548640" y="2743200"/>
+            <a:ext cx="3671316" cy="1143000"/>
+          </a:xfrm>
+          <a:prstGeom prst="rect">
             <a:avLst/>
           </a:prstGeom>
           <a:solidFill>
@@ -6470,8 +6314,8 @@
         </p:nvSpPr>
         <p:spPr>
           <a:xfrm>
-            <a:off x="731520" y="3163824"/>
-            <a:ext cx="493776" cy="274320"/>
+            <a:off x="749808" y="2907792"/>
+            <a:ext cx="3268980" cy="292608"/>
           </a:xfrm>
           <a:prstGeom prst="rect">
             <a:avLst/>
@@ -6486,13 +6330,13 @@
           <a:p>
             <a:pPr algn="l"/>
             <a:r>
-              <a:rPr sz="1200" b="1">
-                <a:solidFill>
-                  <a:srgbClr val="E5B560"/>
+              <a:rPr sz="1700" b="1">
+                <a:solidFill>
+                  <a:srgbClr val="F7F4EE"/>
                 </a:solidFill>
                 <a:latin typeface="Aptos"/>
               </a:rPr>
-              <a:t>01</a:t>
+              <a:t>Concierge pilot</a:t>
             </a:r>
           </a:p>
         </p:txBody>
@@ -6505,8 +6349,8 @@
         </p:nvSpPr>
         <p:spPr>
           <a:xfrm>
-            <a:off x="1261872" y="3108960"/>
-            <a:ext cx="2240280" cy="283464"/>
+            <a:off x="749808" y="3255264"/>
+            <a:ext cx="3268980" cy="475488"/>
           </a:xfrm>
           <a:prstGeom prst="rect">
             <a:avLst/>
@@ -6521,42 +6365,7 @@
           <a:p>
             <a:pPr algn="l"/>
             <a:r>
-              <a:rPr sz="1600" b="1">
-                <a:solidFill>
-                  <a:srgbClr val="F7F4EE"/>
-                </a:solidFill>
-                <a:latin typeface="Aptos"/>
-              </a:rPr>
-              <a:t>Concierge pilot</a:t>
-            </a:r>
-          </a:p>
-        </p:txBody>
-      </p:sp>
-      <p:sp>
-        <p:nvSpPr>
-          <p:cNvPr id="18" name="TextBox 17"/>
-          <p:cNvSpPr txBox="1"/>
-          <p:nvPr/>
-        </p:nvSpPr>
-        <p:spPr>
-          <a:xfrm>
-            <a:off x="3547872" y="3108960"/>
-            <a:ext cx="4361688" cy="347472"/>
-          </a:xfrm>
-          <a:prstGeom prst="rect">
-            <a:avLst/>
-          </a:prstGeom>
-          <a:noFill/>
-        </p:spPr>
-        <p:txBody>
-          <a:bodyPr wrap="square" lIns="0" rIns="0" tIns="0" bIns="0" anchor="t">
-            <a:spAutoFit/>
-          </a:bodyPr>
-          <a:lstStyle/>
-          <a:p>
-            <a:pPr algn="l"/>
-            <a:r>
-              <a:rPr sz="1500" b="0">
+              <a:rPr sz="1200" b="0">
                 <a:solidFill>
                   <a:srgbClr val="B8C0D6"/>
                 </a:solidFill>
@@ -6569,16 +6378,16 @@
       </p:sp>
       <p:sp>
         <p:nvSpPr>
-          <p:cNvPr id="19" name="Rounded Rectangle 18"/>
+          <p:cNvPr id="18" name="semantic.comparison.side.2"/>
           <p:cNvSpPr/>
           <p:nvPr/>
         </p:nvSpPr>
         <p:spPr>
           <a:xfrm>
-            <a:off x="548640" y="3959352"/>
-            <a:ext cx="7543800" cy="749808"/>
-          </a:xfrm>
-          <a:prstGeom prst="roundRect">
+            <a:off x="4421124" y="2743200"/>
+            <a:ext cx="3671316" cy="1143000"/>
+          </a:xfrm>
+          <a:prstGeom prst="rect">
             <a:avLst/>
           </a:prstGeom>
           <a:solidFill>
@@ -6612,14 +6421,14 @@
       </p:sp>
       <p:sp>
         <p:nvSpPr>
-          <p:cNvPr id="20" name="TextBox 19"/>
+          <p:cNvPr id="19" name="TextBox 18"/>
           <p:cNvSpPr txBox="1"/>
           <p:nvPr/>
         </p:nvSpPr>
         <p:spPr>
           <a:xfrm>
-            <a:off x="731520" y="4151376"/>
-            <a:ext cx="493776" cy="274320"/>
+            <a:off x="4622292" y="2907792"/>
+            <a:ext cx="3268980" cy="292608"/>
           </a:xfrm>
           <a:prstGeom prst="rect">
             <a:avLst/>
@@ -6634,27 +6443,27 @@
           <a:p>
             <a:pPr algn="l"/>
             <a:r>
-              <a:rPr sz="1200" b="1">
-                <a:solidFill>
-                  <a:srgbClr val="E5B560"/>
+              <a:rPr sz="1700" b="1">
+                <a:solidFill>
+                  <a:srgbClr val="F7F4EE"/>
                 </a:solidFill>
                 <a:latin typeface="Aptos"/>
               </a:rPr>
-              <a:t>02</a:t>
-            </a:r>
-          </a:p>
-        </p:txBody>
-      </p:sp>
-      <p:sp>
-        <p:nvSpPr>
-          <p:cNvPr id="21" name="TextBox 20"/>
+              <a:t>In-product pilot</a:t>
+            </a:r>
+          </a:p>
+        </p:txBody>
+      </p:sp>
+      <p:sp>
+        <p:nvSpPr>
+          <p:cNvPr id="20" name="TextBox 19"/>
           <p:cNvSpPr txBox="1"/>
           <p:nvPr/>
         </p:nvSpPr>
         <p:spPr>
           <a:xfrm>
-            <a:off x="1261872" y="4096512"/>
-            <a:ext cx="2240280" cy="283464"/>
+            <a:off x="4622292" y="3255264"/>
+            <a:ext cx="3268980" cy="475488"/>
           </a:xfrm>
           <a:prstGeom prst="rect">
             <a:avLst/>
@@ -6669,42 +6478,7 @@
           <a:p>
             <a:pPr algn="l"/>
             <a:r>
-              <a:rPr sz="1600" b="1">
-                <a:solidFill>
-                  <a:srgbClr val="F7F4EE"/>
-                </a:solidFill>
-                <a:latin typeface="Aptos"/>
-              </a:rPr>
-              <a:t>In-product pilot</a:t>
-            </a:r>
-          </a:p>
-        </p:txBody>
-      </p:sp>
-      <p:sp>
-        <p:nvSpPr>
-          <p:cNvPr id="22" name="TextBox 21"/>
-          <p:cNvSpPr txBox="1"/>
-          <p:nvPr/>
-        </p:nvSpPr>
-        <p:spPr>
-          <a:xfrm>
-            <a:off x="3547872" y="4096512"/>
-            <a:ext cx="4361688" cy="347472"/>
-          </a:xfrm>
-          <a:prstGeom prst="rect">
-            <a:avLst/>
-          </a:prstGeom>
-          <a:noFill/>
-        </p:spPr>
-        <p:txBody>
-          <a:bodyPr wrap="square" lIns="0" rIns="0" tIns="0" bIns="0" anchor="t">
-            <a:spAutoFit/>
-          </a:bodyPr>
-          <a:lstStyle/>
-          <a:p>
-            <a:pPr algn="l"/>
-            <a:r>
-              <a:rPr sz="1500" b="0">
+              <a:rPr sz="1200" b="0">
                 <a:solidFill>
                   <a:srgbClr val="B8C0D6"/>
                 </a:solidFill>
@@ -6717,20 +6491,20 @@
       </p:sp>
       <p:sp>
         <p:nvSpPr>
-          <p:cNvPr id="23" name="Rounded Rectangle 22"/>
+          <p:cNvPr id="21" name="semantic.comparison.criterion.1"/>
           <p:cNvSpPr/>
           <p:nvPr/>
         </p:nvSpPr>
         <p:spPr>
           <a:xfrm>
-            <a:off x="548640" y="4946904"/>
-            <a:ext cx="7543800" cy="749808"/>
-          </a:xfrm>
-          <a:prstGeom prst="roundRect">
+            <a:off x="548640" y="4096512"/>
+            <a:ext cx="1417320" cy="438912"/>
+          </a:xfrm>
+          <a:prstGeom prst="rect">
             <a:avLst/>
           </a:prstGeom>
           <a:solidFill>
-            <a:srgbClr val="1B2136"/>
+            <a:srgbClr val="E5B560"/>
           </a:solidFill>
           <a:ln>
             <a:noFill/>
@@ -6760,14 +6534,14 @@
       </p:sp>
       <p:sp>
         <p:nvSpPr>
-          <p:cNvPr id="24" name="TextBox 23"/>
+          <p:cNvPr id="22" name="TextBox 21"/>
           <p:cNvSpPr txBox="1"/>
           <p:nvPr/>
         </p:nvSpPr>
         <p:spPr>
           <a:xfrm>
-            <a:off x="731520" y="5138928"/>
-            <a:ext cx="493776" cy="274320"/>
+            <a:off x="658368" y="4187952"/>
+            <a:ext cx="1188720" cy="228600"/>
           </a:xfrm>
           <a:prstGeom prst="rect">
             <a:avLst/>
@@ -6782,27 +6556,27 @@
           <a:p>
             <a:pPr algn="l"/>
             <a:r>
-              <a:rPr sz="1200" b="1">
-                <a:solidFill>
-                  <a:srgbClr val="E5B560"/>
+              <a:rPr sz="1000" b="1">
+                <a:solidFill>
+                  <a:srgbClr val="F7F4EE"/>
                 </a:solidFill>
                 <a:latin typeface="Aptos"/>
               </a:rPr>
-              <a:t>03</a:t>
-            </a:r>
-          </a:p>
-        </p:txBody>
-      </p:sp>
-      <p:sp>
-        <p:nvSpPr>
-          <p:cNvPr id="25" name="TextBox 24"/>
+              <a:t>Reach versus learning depth</a:t>
+            </a:r>
+          </a:p>
+        </p:txBody>
+      </p:sp>
+      <p:sp>
+        <p:nvSpPr>
+          <p:cNvPr id="23" name="TextBox 22"/>
           <p:cNvSpPr txBox="1"/>
           <p:nvPr/>
         </p:nvSpPr>
         <p:spPr>
           <a:xfrm>
-            <a:off x="1261872" y="5084064"/>
-            <a:ext cx="2240280" cy="283464"/>
+            <a:off x="2148840" y="4169664"/>
+            <a:ext cx="2898648" cy="274320"/>
           </a:xfrm>
           <a:prstGeom prst="rect">
             <a:avLst/>
@@ -6817,27 +6591,27 @@
           <a:p>
             <a:pPr algn="l"/>
             <a:r>
-              <a:rPr sz="1600" b="1">
-                <a:solidFill>
-                  <a:srgbClr val="F7F4EE"/>
+              <a:rPr sz="1000" b="0">
+                <a:solidFill>
+                  <a:srgbClr val="B8C0D6"/>
                 </a:solidFill>
                 <a:latin typeface="Aptos"/>
               </a:rPr>
-              <a:t>Decision lens</a:t>
-            </a:r>
-          </a:p>
-        </p:txBody>
-      </p:sp>
-      <p:sp>
-        <p:nvSpPr>
-          <p:cNvPr id="26" name="TextBox 25"/>
+              <a:t>A human-led cohort using the current product and a shared checklist.</a:t>
+            </a:r>
+          </a:p>
+        </p:txBody>
+      </p:sp>
+      <p:sp>
+        <p:nvSpPr>
+          <p:cNvPr id="24" name="TextBox 23"/>
           <p:cNvSpPr txBox="1"/>
           <p:nvPr/>
         </p:nvSpPr>
         <p:spPr>
           <a:xfrm>
-            <a:off x="3547872" y="5084064"/>
-            <a:ext cx="4361688" cy="347472"/>
+            <a:off x="5120640" y="4169664"/>
+            <a:ext cx="2971800" cy="274320"/>
           </a:xfrm>
           <a:prstGeom prst="rect">
             <a:avLst/>
@@ -6852,20 +6626,20 @@
           <a:p>
             <a:pPr algn="l"/>
             <a:r>
-              <a:rPr sz="1500" b="0">
+              <a:rPr sz="1000" b="0">
                 <a:solidFill>
                   <a:srgbClr val="B8C0D6"/>
                 </a:solidFill>
                 <a:latin typeface="Aptos"/>
               </a:rPr>
-              <a:t>No new platform</a:t>
-            </a:r>
-          </a:p>
-        </p:txBody>
-      </p:sp>
-      <p:sp>
-        <p:nvSpPr>
-          <p:cNvPr id="27" name="TextBox 26"/>
+              <a:t>A guided workflow implemented inside the current product experience.</a:t>
+            </a:r>
+          </a:p>
+        </p:txBody>
+      </p:sp>
+      <p:sp>
+        <p:nvSpPr>
+          <p:cNvPr id="25" name="TextBox 24"/>
           <p:cNvSpPr txBox="1"/>
           <p:nvPr/>
         </p:nvSpPr>
@@ -6900,13 +6674,13 @@
       </p:sp>
       <p:sp>
         <p:nvSpPr>
-          <p:cNvPr id="28" name="TextBox 27"/>
+          <p:cNvPr id="26" name="TextBox 25"/>
           <p:cNvSpPr txBox="1"/>
           <p:nvPr/>
         </p:nvSpPr>
         <p:spPr>
           <a:xfrm>
-            <a:off x="11064240" y="6428232"/>
+            <a:off x="11094415" y="6428232"/>
             <a:ext cx="594360" cy="201168"/>
           </a:xfrm>
           <a:prstGeom prst="rect">
@@ -7343,14 +7117,92 @@
       </p:sp>
       <p:sp>
         <p:nvSpPr>
-          <p:cNvPr id="12" name="Rounded Rectangle 11"/>
+          <p:cNvPr id="12" name="semantic.decision.statement"/>
           <p:cNvSpPr/>
           <p:nvPr/>
         </p:nvSpPr>
         <p:spPr>
           <a:xfrm>
-            <a:off x="548640" y="2971800"/>
-            <a:ext cx="7132320" cy="749808"/>
+            <a:off x="548640" y="2743200"/>
+            <a:ext cx="7132320" cy="731520"/>
+          </a:xfrm>
+          <a:prstGeom prst="chevron">
+            <a:avLst/>
+          </a:prstGeom>
+          <a:solidFill>
+            <a:srgbClr val="E5B560"/>
+          </a:solidFill>
+          <a:ln>
+            <a:noFill/>
+          </a:ln>
+        </p:spPr>
+        <p:style>
+          <a:lnRef idx="1">
+            <a:schemeClr val="accent1"/>
+          </a:lnRef>
+          <a:fillRef idx="3">
+            <a:schemeClr val="accent1"/>
+          </a:fillRef>
+          <a:effectRef idx="2">
+            <a:schemeClr val="accent1"/>
+          </a:effectRef>
+          <a:fontRef idx="minor">
+            <a:schemeClr val="lt1"/>
+          </a:fontRef>
+        </p:style>
+        <p:txBody>
+          <a:bodyPr rtlCol="0" anchor="ctr"/>
+          <a:lstStyle/>
+          <a:p>
+            <a:pPr algn="ctr"/>
+          </a:p>
+        </p:txBody>
+      </p:sp>
+      <p:sp>
+        <p:nvSpPr>
+          <p:cNvPr id="13" name="TextBox 12"/>
+          <p:cNvSpPr txBox="1"/>
+          <p:nvPr/>
+        </p:nvSpPr>
+        <p:spPr>
+          <a:xfrm>
+            <a:off x="768096" y="2926080"/>
+            <a:ext cx="6492240" cy="329184"/>
+          </a:xfrm>
+          <a:prstGeom prst="rect">
+            <a:avLst/>
+          </a:prstGeom>
+          <a:noFill/>
+        </p:spPr>
+        <p:txBody>
+          <a:bodyPr wrap="square" lIns="0" rIns="0" tIns="0" bIns="0" anchor="t">
+            <a:spAutoFit/>
+          </a:bodyPr>
+          <a:lstStyle/>
+          <a:p>
+            <a:pPr algn="l"/>
+            <a:r>
+              <a:rPr sz="1600" b="1">
+                <a:solidFill>
+                  <a:srgbClr val="101425"/>
+                </a:solidFill>
+                <a:latin typeface="Aptos"/>
+              </a:rPr>
+              <a:t>Choose the onboarding pilot for the next release</a:t>
+            </a:r>
+          </a:p>
+        </p:txBody>
+      </p:sp>
+      <p:sp>
+        <p:nvSpPr>
+          <p:cNvPr id="14" name="semantic.decision.option.1"/>
+          <p:cNvSpPr/>
+          <p:nvPr/>
+        </p:nvSpPr>
+        <p:spPr>
+          <a:xfrm>
+            <a:off x="548640" y="3730752"/>
+            <a:ext cx="3456432" cy="1024128"/>
           </a:xfrm>
           <a:prstGeom prst="roundRect">
             <a:avLst/>
@@ -7386,14 +7238,14 @@
       </p:sp>
       <p:sp>
         <p:nvSpPr>
-          <p:cNvPr id="13" name="TextBox 12"/>
+          <p:cNvPr id="15" name="TextBox 14"/>
           <p:cNvSpPr txBox="1"/>
           <p:nvPr/>
         </p:nvSpPr>
         <p:spPr>
           <a:xfrm>
-            <a:off x="731520" y="3163824"/>
-            <a:ext cx="493776" cy="274320"/>
+            <a:off x="694944" y="3877056"/>
+            <a:ext cx="3163824" cy="256032"/>
           </a:xfrm>
           <a:prstGeom prst="rect">
             <a:avLst/>
@@ -7408,27 +7260,27 @@
           <a:p>
             <a:pPr algn="l"/>
             <a:r>
-              <a:rPr sz="1200" b="1">
-                <a:solidFill>
-                  <a:srgbClr val="E5B560"/>
+              <a:rPr sz="1300" b="1">
+                <a:solidFill>
+                  <a:srgbClr val="F7F4EE"/>
                 </a:solidFill>
                 <a:latin typeface="Aptos"/>
               </a:rPr>
-              <a:t>01</a:t>
-            </a:r>
-          </a:p>
-        </p:txBody>
-      </p:sp>
-      <p:sp>
-        <p:nvSpPr>
-          <p:cNvPr id="14" name="TextBox 13"/>
+              <a:t>Concierge pilot</a:t>
+            </a:r>
+          </a:p>
+        </p:txBody>
+      </p:sp>
+      <p:sp>
+        <p:nvSpPr>
+          <p:cNvPr id="16" name="TextBox 15"/>
           <p:cNvSpPr txBox="1"/>
           <p:nvPr/>
         </p:nvSpPr>
         <p:spPr>
           <a:xfrm>
-            <a:off x="1261872" y="3108960"/>
-            <a:ext cx="2240280" cy="283464"/>
+            <a:off x="694944" y="4187952"/>
+            <a:ext cx="3163824" cy="384048"/>
           </a:xfrm>
           <a:prstGeom prst="rect">
             <a:avLst/>
@@ -7443,62 +7295,27 @@
           <a:p>
             <a:pPr algn="l"/>
             <a:r>
-              <a:rPr sz="1600" b="1">
-                <a:solidFill>
-                  <a:srgbClr val="F7F4EE"/>
+              <a:rPr sz="900" b="0">
+                <a:solidFill>
+                  <a:srgbClr val="B8C0D6"/>
                 </a:solidFill>
                 <a:latin typeface="Aptos"/>
               </a:rPr>
-              <a:t>Trade-off 1</a:t>
-            </a:r>
-          </a:p>
-        </p:txBody>
-      </p:sp>
-      <p:sp>
-        <p:nvSpPr>
-          <p:cNvPr id="15" name="TextBox 14"/>
-          <p:cNvSpPr txBox="1"/>
-          <p:nvPr/>
-        </p:nvSpPr>
-        <p:spPr>
-          <a:xfrm>
-            <a:off x="3547872" y="3108960"/>
-            <a:ext cx="3950208" cy="347472"/>
-          </a:xfrm>
-          <a:prstGeom prst="rect">
-            <a:avLst/>
-          </a:prstGeom>
-          <a:noFill/>
-        </p:spPr>
-        <p:txBody>
-          <a:bodyPr wrap="square" lIns="0" rIns="0" tIns="0" bIns="0" anchor="t">
-            <a:spAutoFit/>
-          </a:bodyPr>
-          <a:lstStyle/>
-          <a:p>
-            <a:pPr algn="l"/>
-            <a:r>
-              <a:rPr sz="1500" b="0">
-                <a:solidFill>
-                  <a:srgbClr val="B8C0D6"/>
-                </a:solidFill>
-                <a:latin typeface="Aptos"/>
-              </a:rPr>
-              <a:t>Reach versus learning depth</a:t>
-            </a:r>
-          </a:p>
-        </p:txBody>
-      </p:sp>
-      <p:sp>
-        <p:nvSpPr>
-          <p:cNvPr id="16" name="Rounded Rectangle 15"/>
+              <a:t>A human-led cohort using the current product and a shared checklist.</a:t>
+            </a:r>
+          </a:p>
+        </p:txBody>
+      </p:sp>
+      <p:sp>
+        <p:nvSpPr>
+          <p:cNvPr id="17" name="semantic.decision.option.2"/>
           <p:cNvSpPr/>
           <p:nvPr/>
         </p:nvSpPr>
         <p:spPr>
           <a:xfrm>
-            <a:off x="548640" y="3959352"/>
-            <a:ext cx="7132320" cy="749808"/>
+            <a:off x="4224528" y="3730752"/>
+            <a:ext cx="3456432" cy="1024128"/>
           </a:xfrm>
           <a:prstGeom prst="roundRect">
             <a:avLst/>
@@ -7534,14 +7351,14 @@
       </p:sp>
       <p:sp>
         <p:nvSpPr>
-          <p:cNvPr id="17" name="TextBox 16"/>
+          <p:cNvPr id="18" name="TextBox 17"/>
           <p:cNvSpPr txBox="1"/>
           <p:nvPr/>
         </p:nvSpPr>
         <p:spPr>
           <a:xfrm>
-            <a:off x="731520" y="4151376"/>
-            <a:ext cx="493776" cy="274320"/>
+            <a:off x="4370832" y="3877056"/>
+            <a:ext cx="3163824" cy="256032"/>
           </a:xfrm>
           <a:prstGeom prst="rect">
             <a:avLst/>
@@ -7556,27 +7373,27 @@
           <a:p>
             <a:pPr algn="l"/>
             <a:r>
-              <a:rPr sz="1200" b="1">
-                <a:solidFill>
-                  <a:srgbClr val="E5B560"/>
+              <a:rPr sz="1300" b="1">
+                <a:solidFill>
+                  <a:srgbClr val="F7F4EE"/>
                 </a:solidFill>
                 <a:latin typeface="Aptos"/>
               </a:rPr>
-              <a:t>02</a:t>
-            </a:r>
-          </a:p>
-        </p:txBody>
-      </p:sp>
-      <p:sp>
-        <p:nvSpPr>
-          <p:cNvPr id="18" name="TextBox 17"/>
+              <a:t>In-product pilot</a:t>
+            </a:r>
+          </a:p>
+        </p:txBody>
+      </p:sp>
+      <p:sp>
+        <p:nvSpPr>
+          <p:cNvPr id="19" name="TextBox 18"/>
           <p:cNvSpPr txBox="1"/>
           <p:nvPr/>
         </p:nvSpPr>
         <p:spPr>
           <a:xfrm>
-            <a:off x="1261872" y="4096512"/>
-            <a:ext cx="2240280" cy="283464"/>
+            <a:off x="4370832" y="4187952"/>
+            <a:ext cx="3163824" cy="384048"/>
           </a:xfrm>
           <a:prstGeom prst="rect">
             <a:avLst/>
@@ -7591,68 +7408,33 @@
           <a:p>
             <a:pPr algn="l"/>
             <a:r>
-              <a:rPr sz="1600" b="1">
-                <a:solidFill>
-                  <a:srgbClr val="F7F4EE"/>
+              <a:rPr sz="900" b="0">
+                <a:solidFill>
+                  <a:srgbClr val="B8C0D6"/>
                 </a:solidFill>
                 <a:latin typeface="Aptos"/>
               </a:rPr>
-              <a:t>Trade-off 2</a:t>
-            </a:r>
-          </a:p>
-        </p:txBody>
-      </p:sp>
-      <p:sp>
-        <p:nvSpPr>
-          <p:cNvPr id="19" name="TextBox 18"/>
-          <p:cNvSpPr txBox="1"/>
-          <p:nvPr/>
-        </p:nvSpPr>
-        <p:spPr>
-          <a:xfrm>
-            <a:off x="3547872" y="4096512"/>
-            <a:ext cx="3950208" cy="347472"/>
-          </a:xfrm>
-          <a:prstGeom prst="rect">
-            <a:avLst/>
-          </a:prstGeom>
-          <a:noFill/>
-        </p:spPr>
-        <p:txBody>
-          <a:bodyPr wrap="square" lIns="0" rIns="0" tIns="0" bIns="0" anchor="t">
-            <a:spAutoFit/>
-          </a:bodyPr>
-          <a:lstStyle/>
-          <a:p>
-            <a:pPr algn="l"/>
-            <a:r>
-              <a:rPr sz="1500" b="0">
-                <a:solidFill>
-                  <a:srgbClr val="B8C0D6"/>
-                </a:solidFill>
-                <a:latin typeface="Aptos"/>
-              </a:rPr>
-              <a:t>Speed versus automation</a:t>
-            </a:r>
-          </a:p>
-        </p:txBody>
-      </p:sp>
-      <p:sp>
-        <p:nvSpPr>
-          <p:cNvPr id="20" name="Rounded Rectangle 19"/>
+              <a:t>A guided workflow implemented inside the current product experience.</a:t>
+            </a:r>
+          </a:p>
+        </p:txBody>
+      </p:sp>
+      <p:sp>
+        <p:nvSpPr>
+          <p:cNvPr id="20" name="semantic.decision.rationale"/>
           <p:cNvSpPr/>
           <p:nvPr/>
         </p:nvSpPr>
         <p:spPr>
           <a:xfrm>
-            <a:off x="548640" y="4946904"/>
-            <a:ext cx="7132320" cy="749808"/>
-          </a:xfrm>
-          <a:prstGeom prst="roundRect">
+            <a:off x="548640" y="5010912"/>
+            <a:ext cx="7132320" cy="694944"/>
+          </a:xfrm>
+          <a:prstGeom prst="rect">
             <a:avLst/>
           </a:prstGeom>
           <a:solidFill>
-            <a:srgbClr val="1B2136"/>
+            <a:srgbClr val="262E49"/>
           </a:solidFill>
           <a:ln>
             <a:noFill/>
@@ -7688,8 +7470,8 @@
         </p:nvSpPr>
         <p:spPr>
           <a:xfrm>
-            <a:off x="731520" y="5138928"/>
-            <a:ext cx="493776" cy="274320"/>
+            <a:off x="731520" y="5184648"/>
+            <a:ext cx="6766560" cy="292608"/>
           </a:xfrm>
           <a:prstGeom prst="rect">
             <a:avLst/>
@@ -7704,13 +7486,13 @@
           <a:p>
             <a:pPr algn="l"/>
             <a:r>
-              <a:rPr sz="1200" b="1">
-                <a:solidFill>
-                  <a:srgbClr val="E5B560"/>
+              <a:rPr sz="1100" b="1">
+                <a:solidFill>
+                  <a:srgbClr val="F7F4EE"/>
                 </a:solidFill>
                 <a:latin typeface="Aptos"/>
               </a:rPr>
-              <a:t>03</a:t>
+              <a:t>RATIONALE  Reach versus learning depth; Speed versus automation  ·  OWNER  Onboarding lead</a:t>
             </a:r>
           </a:p>
         </p:txBody>
@@ -7723,8 +7505,8 @@
         </p:nvSpPr>
         <p:spPr>
           <a:xfrm>
-            <a:off x="1261872" y="5084064"/>
-            <a:ext cx="2240280" cy="283464"/>
+            <a:off x="502920" y="6446520"/>
+            <a:ext cx="5669280" cy="201168"/>
           </a:xfrm>
           <a:prstGeom prst="rect">
             <a:avLst/>
@@ -7739,76 +7521,6 @@
           <a:p>
             <a:pPr algn="l"/>
             <a:r>
-              <a:rPr sz="1600" b="1">
-                <a:solidFill>
-                  <a:srgbClr val="F7F4EE"/>
-                </a:solidFill>
-                <a:latin typeface="Aptos"/>
-              </a:rPr>
-              <a:t>What the decision protects</a:t>
-            </a:r>
-          </a:p>
-        </p:txBody>
-      </p:sp>
-      <p:sp>
-        <p:nvSpPr>
-          <p:cNvPr id="23" name="TextBox 22"/>
-          <p:cNvSpPr txBox="1"/>
-          <p:nvPr/>
-        </p:nvSpPr>
-        <p:spPr>
-          <a:xfrm>
-            <a:off x="3547872" y="5084064"/>
-            <a:ext cx="3950208" cy="347472"/>
-          </a:xfrm>
-          <a:prstGeom prst="rect">
-            <a:avLst/>
-          </a:prstGeom>
-          <a:noFill/>
-        </p:spPr>
-        <p:txBody>
-          <a:bodyPr wrap="square" lIns="0" rIns="0" tIns="0" bIns="0" anchor="t">
-            <a:spAutoFit/>
-          </a:bodyPr>
-          <a:lstStyle/>
-          <a:p>
-            <a:pPr algn="l"/>
-            <a:r>
-              <a:rPr sz="1500" b="0">
-                <a:solidFill>
-                  <a:srgbClr val="B8C0D6"/>
-                </a:solidFill>
-                <a:latin typeface="Aptos"/>
-              </a:rPr>
-              <a:t>Approve one measurable first-30-day onboarding experience</a:t>
-            </a:r>
-          </a:p>
-        </p:txBody>
-      </p:sp>
-      <p:sp>
-        <p:nvSpPr>
-          <p:cNvPr id="24" name="TextBox 23"/>
-          <p:cNvSpPr txBox="1"/>
-          <p:nvPr/>
-        </p:nvSpPr>
-        <p:spPr>
-          <a:xfrm>
-            <a:off x="502920" y="6446520"/>
-            <a:ext cx="5669280" cy="201168"/>
-          </a:xfrm>
-          <a:prstGeom prst="rect">
-            <a:avLst/>
-          </a:prstGeom>
-          <a:noFill/>
-        </p:spPr>
-        <p:txBody>
-          <a:bodyPr wrap="square" lIns="0" rIns="0" tIns="0" bIns="0" anchor="t">
-            <a:spAutoFit/>
-          </a:bodyPr>
-          <a:lstStyle/>
-          <a:p>
-            <a:pPr algn="l"/>
-            <a:r>
               <a:rPr sz="900" b="0">
                 <a:solidFill>
                   <a:srgbClr val="B8C0D6"/>
@@ -7822,13 +7534,13 @@
       </p:sp>
       <p:sp>
         <p:nvSpPr>
-          <p:cNvPr id="25" name="TextBox 24"/>
+          <p:cNvPr id="23" name="TextBox 22"/>
           <p:cNvSpPr txBox="1"/>
           <p:nvPr/>
         </p:nvSpPr>
         <p:spPr>
           <a:xfrm>
-            <a:off x="11064240" y="6428232"/>
+            <a:off x="11094415" y="6428232"/>
             <a:ext cx="594360" cy="201168"/>
           </a:xfrm>
           <a:prstGeom prst="rect">
@@ -8351,20 +8063,20 @@
       </p:sp>
       <p:sp>
         <p:nvSpPr>
-          <p:cNvPr id="14" name="Rounded Rectangle 13"/>
+          <p:cNvPr id="14" name="semantic.timeline.connector"/>
           <p:cNvSpPr/>
           <p:nvPr/>
         </p:nvSpPr>
         <p:spPr>
           <a:xfrm>
-            <a:off x="4160520" y="2971800"/>
-            <a:ext cx="7132320" cy="749808"/>
-          </a:xfrm>
-          <a:prstGeom prst="roundRect">
+            <a:off x="4480560" y="3218688"/>
+            <a:ext cx="6492240" cy="73152"/>
+          </a:xfrm>
+          <a:prstGeom prst="rect">
             <a:avLst/>
           </a:prstGeom>
           <a:solidFill>
-            <a:srgbClr val="1B2136"/>
+            <a:srgbClr val="745B36"/>
           </a:solidFill>
           <a:ln>
             <a:noFill/>
@@ -8394,125 +8106,20 @@
       </p:sp>
       <p:sp>
         <p:nvSpPr>
-          <p:cNvPr id="15" name="TextBox 14"/>
-          <p:cNvSpPr txBox="1"/>
-          <p:nvPr/>
-        </p:nvSpPr>
-        <p:spPr>
-          <a:xfrm>
-            <a:off x="4343400" y="3163824"/>
-            <a:ext cx="493776" cy="274320"/>
-          </a:xfrm>
-          <a:prstGeom prst="rect">
-            <a:avLst/>
-          </a:prstGeom>
-          <a:noFill/>
-        </p:spPr>
-        <p:txBody>
-          <a:bodyPr wrap="square" lIns="0" rIns="0" tIns="0" bIns="0" anchor="t">
-            <a:spAutoFit/>
-          </a:bodyPr>
-          <a:lstStyle/>
-          <a:p>
-            <a:pPr algn="l"/>
-            <a:r>
-              <a:rPr sz="1200" b="1">
-                <a:solidFill>
-                  <a:srgbClr val="E5B560"/>
-                </a:solidFill>
-                <a:latin typeface="Aptos"/>
-              </a:rPr>
-              <a:t>01</a:t>
-            </a:r>
-          </a:p>
-        </p:txBody>
-      </p:sp>
-      <p:sp>
-        <p:nvSpPr>
-          <p:cNvPr id="16" name="TextBox 15"/>
-          <p:cNvSpPr txBox="1"/>
-          <p:nvPr/>
-        </p:nvSpPr>
-        <p:spPr>
-          <a:xfrm>
-            <a:off x="4873752" y="3108960"/>
-            <a:ext cx="2240280" cy="283464"/>
-          </a:xfrm>
-          <a:prstGeom prst="rect">
-            <a:avLst/>
-          </a:prstGeom>
-          <a:noFill/>
-        </p:spPr>
-        <p:txBody>
-          <a:bodyPr wrap="square" lIns="0" rIns="0" tIns="0" bIns="0" anchor="t">
-            <a:spAutoFit/>
-          </a:bodyPr>
-          <a:lstStyle/>
-          <a:p>
-            <a:pPr algn="l"/>
-            <a:r>
-              <a:rPr sz="1600" b="1">
-                <a:solidFill>
-                  <a:srgbClr val="F7F4EE"/>
-                </a:solidFill>
-                <a:latin typeface="Aptos"/>
-              </a:rPr>
-              <a:t>Owner</a:t>
-            </a:r>
-          </a:p>
-        </p:txBody>
-      </p:sp>
-      <p:sp>
-        <p:nvSpPr>
-          <p:cNvPr id="17" name="TextBox 16"/>
-          <p:cNvSpPr txBox="1"/>
-          <p:nvPr/>
-        </p:nvSpPr>
-        <p:spPr>
-          <a:xfrm>
-            <a:off x="7159752" y="3108960"/>
-            <a:ext cx="3950208" cy="347472"/>
-          </a:xfrm>
-          <a:prstGeom prst="rect">
-            <a:avLst/>
-          </a:prstGeom>
-          <a:noFill/>
-        </p:spPr>
-        <p:txBody>
-          <a:bodyPr wrap="square" lIns="0" rIns="0" tIns="0" bIns="0" anchor="t">
-            <a:spAutoFit/>
-          </a:bodyPr>
-          <a:lstStyle/>
-          <a:p>
-            <a:pPr algn="l"/>
-            <a:r>
-              <a:rPr sz="1500" b="0">
-                <a:solidFill>
-                  <a:srgbClr val="B8C0D6"/>
-                </a:solidFill>
-                <a:latin typeface="Aptos"/>
-              </a:rPr>
-              <a:t>Onboarding lead</a:t>
-            </a:r>
-          </a:p>
-        </p:txBody>
-      </p:sp>
-      <p:sp>
-        <p:nvSpPr>
-          <p:cNvPr id="18" name="Rounded Rectangle 17"/>
+          <p:cNvPr id="15" name="semantic.timeline.step.1"/>
           <p:cNvSpPr/>
           <p:nvPr/>
         </p:nvSpPr>
         <p:spPr>
           <a:xfrm>
-            <a:off x="4160520" y="3959352"/>
-            <a:ext cx="7132320" cy="749808"/>
-          </a:xfrm>
-          <a:prstGeom prst="roundRect">
+            <a:off x="5760720" y="3054096"/>
+            <a:ext cx="365760" cy="365760"/>
+          </a:xfrm>
+          <a:prstGeom prst="ellipse">
             <a:avLst/>
           </a:prstGeom>
           <a:solidFill>
-            <a:srgbClr val="262E49"/>
+            <a:srgbClr val="E5B560"/>
           </a:solidFill>
           <a:ln>
             <a:noFill/>
@@ -8542,14 +8149,14 @@
       </p:sp>
       <p:sp>
         <p:nvSpPr>
-          <p:cNvPr id="19" name="TextBox 18"/>
+          <p:cNvPr id="16" name="TextBox 15"/>
           <p:cNvSpPr txBox="1"/>
           <p:nvPr/>
         </p:nvSpPr>
         <p:spPr>
           <a:xfrm>
-            <a:off x="4343400" y="4151376"/>
-            <a:ext cx="493776" cy="274320"/>
+            <a:off x="4233672" y="2743200"/>
+            <a:ext cx="3419856" cy="256032"/>
           </a:xfrm>
           <a:prstGeom prst="rect">
             <a:avLst/>
@@ -8562,29 +8169,29 @@
           </a:bodyPr>
           <a:lstStyle/>
           <a:p>
-            <a:pPr algn="l"/>
-            <a:r>
-              <a:rPr sz="1200" b="1">
+            <a:pPr algn="ctr"/>
+            <a:r>
+              <a:rPr sz="1100" b="1">
                 <a:solidFill>
                   <a:srgbClr val="E5B560"/>
                 </a:solidFill>
                 <a:latin typeface="Aptos"/>
               </a:rPr>
-              <a:t>02</a:t>
-            </a:r>
-          </a:p>
-        </p:txBody>
-      </p:sp>
-      <p:sp>
-        <p:nvSpPr>
-          <p:cNvPr id="20" name="TextBox 19"/>
+              <a:t>Next</a:t>
+            </a:r>
+          </a:p>
+        </p:txBody>
+      </p:sp>
+      <p:sp>
+        <p:nvSpPr>
+          <p:cNvPr id="17" name="TextBox 16"/>
           <p:cNvSpPr txBox="1"/>
           <p:nvPr/>
         </p:nvSpPr>
         <p:spPr>
           <a:xfrm>
-            <a:off x="4873752" y="4096512"/>
-            <a:ext cx="2240280" cy="283464"/>
+            <a:off x="4233672" y="3675887"/>
+            <a:ext cx="3419856" cy="713232"/>
           </a:xfrm>
           <a:prstGeom prst="rect">
             <a:avLst/>
@@ -8597,29 +8204,29 @@
           </a:bodyPr>
           <a:lstStyle/>
           <a:p>
-            <a:pPr algn="l"/>
-            <a:r>
-              <a:rPr sz="1600" b="1">
+            <a:pPr algn="ctr"/>
+            <a:r>
+              <a:rPr sz="1400" b="1">
                 <a:solidFill>
                   <a:srgbClr val="F7F4EE"/>
                 </a:solidFill>
                 <a:latin typeface="Aptos"/>
               </a:rPr>
-              <a:t>Next step</a:t>
-            </a:r>
-          </a:p>
-        </p:txBody>
-      </p:sp>
-      <p:sp>
-        <p:nvSpPr>
-          <p:cNvPr id="21" name="TextBox 20"/>
+              <a:t>Run a five-customer concierge pilot and review the evidence</a:t>
+            </a:r>
+          </a:p>
+        </p:txBody>
+      </p:sp>
+      <p:sp>
+        <p:nvSpPr>
+          <p:cNvPr id="18" name="TextBox 17"/>
           <p:cNvSpPr txBox="1"/>
           <p:nvPr/>
         </p:nvSpPr>
         <p:spPr>
           <a:xfrm>
-            <a:off x="7159752" y="4096512"/>
-            <a:ext cx="3950208" cy="347472"/>
+            <a:off x="4233672" y="4553712"/>
+            <a:ext cx="3419856" cy="329184"/>
           </a:xfrm>
           <a:prstGeom prst="rect">
             <a:avLst/>
@@ -8632,35 +8239,35 @@
           </a:bodyPr>
           <a:lstStyle/>
           <a:p>
-            <a:pPr algn="l"/>
-            <a:r>
-              <a:rPr sz="1500" b="0">
+            <a:pPr algn="ctr"/>
+            <a:r>
+              <a:rPr sz="1000" b="0">
                 <a:solidFill>
                   <a:srgbClr val="B8C0D6"/>
                 </a:solidFill>
                 <a:latin typeface="Aptos"/>
               </a:rPr>
-              <a:t>Run a five-customer concierge pilot and review the evidence</a:t>
-            </a:r>
-          </a:p>
-        </p:txBody>
-      </p:sp>
-      <p:sp>
-        <p:nvSpPr>
-          <p:cNvPr id="22" name="Rounded Rectangle 21"/>
+              <a:t>Onboarding lead</a:t>
+            </a:r>
+          </a:p>
+        </p:txBody>
+      </p:sp>
+      <p:sp>
+        <p:nvSpPr>
+          <p:cNvPr id="19" name="semantic.timeline.step.2"/>
           <p:cNvSpPr/>
           <p:nvPr/>
         </p:nvSpPr>
         <p:spPr>
           <a:xfrm>
-            <a:off x="4160520" y="4946904"/>
-            <a:ext cx="7132320" cy="749808"/>
-          </a:xfrm>
-          <a:prstGeom prst="roundRect">
+            <a:off x="9326880" y="3054096"/>
+            <a:ext cx="365760" cy="365760"/>
+          </a:xfrm>
+          <a:prstGeom prst="ellipse">
             <a:avLst/>
           </a:prstGeom>
           <a:solidFill>
-            <a:srgbClr val="1B2136"/>
+            <a:srgbClr val="E5B560"/>
           </a:solidFill>
           <a:ln>
             <a:noFill/>
@@ -8690,14 +8297,14 @@
       </p:sp>
       <p:sp>
         <p:nvSpPr>
-          <p:cNvPr id="23" name="TextBox 22"/>
+          <p:cNvPr id="20" name="TextBox 19"/>
           <p:cNvSpPr txBox="1"/>
           <p:nvPr/>
         </p:nvSpPr>
         <p:spPr>
           <a:xfrm>
-            <a:off x="4343400" y="5138928"/>
-            <a:ext cx="493776" cy="274320"/>
+            <a:off x="7799832" y="2743200"/>
+            <a:ext cx="3419856" cy="256032"/>
           </a:xfrm>
           <a:prstGeom prst="rect">
             <a:avLst/>
@@ -8710,29 +8317,29 @@
           </a:bodyPr>
           <a:lstStyle/>
           <a:p>
-            <a:pPr algn="l"/>
-            <a:r>
-              <a:rPr sz="1200" b="1">
+            <a:pPr algn="ctr"/>
+            <a:r>
+              <a:rPr sz="1100" b="1">
                 <a:solidFill>
                   <a:srgbClr val="E5B560"/>
                 </a:solidFill>
                 <a:latin typeface="Aptos"/>
               </a:rPr>
-              <a:t>03</a:t>
-            </a:r>
-          </a:p>
-        </p:txBody>
-      </p:sp>
-      <p:sp>
-        <p:nvSpPr>
-          <p:cNvPr id="24" name="TextBox 23"/>
+              <a:t>2026-09-30</a:t>
+            </a:r>
+          </a:p>
+        </p:txBody>
+      </p:sp>
+      <p:sp>
+        <p:nvSpPr>
+          <p:cNvPr id="21" name="TextBox 20"/>
           <p:cNvSpPr txBox="1"/>
           <p:nvPr/>
         </p:nvSpPr>
         <p:spPr>
           <a:xfrm>
-            <a:off x="4873752" y="5084064"/>
-            <a:ext cx="2240280" cy="283464"/>
+            <a:off x="7799832" y="3675887"/>
+            <a:ext cx="3419856" cy="713232"/>
           </a:xfrm>
           <a:prstGeom prst="rect">
             <a:avLst/>
@@ -8745,29 +8352,29 @@
           </a:bodyPr>
           <a:lstStyle/>
           <a:p>
-            <a:pPr algn="l"/>
-            <a:r>
-              <a:rPr sz="1600" b="1">
+            <a:pPr algn="ctr"/>
+            <a:r>
+              <a:rPr sz="1400" b="1">
                 <a:solidFill>
                   <a:srgbClr val="F7F4EE"/>
                 </a:solidFill>
                 <a:latin typeface="Aptos"/>
               </a:rPr>
-              <a:t>Review date</a:t>
-            </a:r>
-          </a:p>
-        </p:txBody>
-      </p:sp>
-      <p:sp>
-        <p:nvSpPr>
-          <p:cNvPr id="25" name="TextBox 24"/>
+              <a:t>Review the author-supplied evidence and decide whether to continue</a:t>
+            </a:r>
+          </a:p>
+        </p:txBody>
+      </p:sp>
+      <p:sp>
+        <p:nvSpPr>
+          <p:cNvPr id="22" name="TextBox 21"/>
           <p:cNvSpPr txBox="1"/>
           <p:nvPr/>
         </p:nvSpPr>
         <p:spPr>
           <a:xfrm>
-            <a:off x="7159752" y="5084064"/>
-            <a:ext cx="3950208" cy="347472"/>
+            <a:off x="7799832" y="4553712"/>
+            <a:ext cx="3419856" cy="329184"/>
           </a:xfrm>
           <a:prstGeom prst="rect">
             <a:avLst/>
@@ -8780,22 +8387,22 @@
           </a:bodyPr>
           <a:lstStyle/>
           <a:p>
-            <a:pPr algn="l"/>
-            <a:r>
-              <a:rPr sz="1500" b="0">
+            <a:pPr algn="ctr"/>
+            <a:r>
+              <a:rPr sz="1000" b="0">
                 <a:solidFill>
                   <a:srgbClr val="B8C0D6"/>
                 </a:solidFill>
                 <a:latin typeface="Aptos"/>
               </a:rPr>
-              <a:t>2026-09-30</a:t>
-            </a:r>
-          </a:p>
-        </p:txBody>
-      </p:sp>
-      <p:sp>
-        <p:nvSpPr>
-          <p:cNvPr id="26" name="TextBox 25"/>
+              <a:t>Onboarding lead</a:t>
+            </a:r>
+          </a:p>
+        </p:txBody>
+      </p:sp>
+      <p:sp>
+        <p:nvSpPr>
+          <p:cNvPr id="23" name="TextBox 22"/>
           <p:cNvSpPr txBox="1"/>
           <p:nvPr/>
         </p:nvSpPr>
@@ -8830,13 +8437,13 @@
       </p:sp>
       <p:sp>
         <p:nvSpPr>
-          <p:cNvPr id="27" name="TextBox 26"/>
+          <p:cNvPr id="24" name="TextBox 23"/>
           <p:cNvSpPr txBox="1"/>
           <p:nvPr/>
         </p:nvSpPr>
         <p:spPr>
           <a:xfrm>
-            <a:off x="11064240" y="6428232"/>
+            <a:off x="11094415" y="6428232"/>
             <a:ext cx="594360" cy="201168"/>
           </a:xfrm>
           <a:prstGeom prst="rect">

</xml_diff>